<commit_message>
Ajustes, PPT em construção v3
</commit_message>
<xml_diff>
--- a/01_app_notellm/docs/APRESENTACAO_PETROBRAS.pptx
+++ b/01_app_notellm/docs/APRESENTACAO_PETROBRAS.pptx
@@ -25950,7 +25950,7 @@
                 </a:solidFill>
                 <a:latin typeface="Segoe UI"/>
               </a:rPr>
-              <a:t>32</a:t>
+              <a:t>33</a:t>
             </a:r>
           </a:p>
         </p:txBody>
@@ -29577,7 +29577,7 @@
                 </a:solidFill>
                 <a:latin typeface="Segoe UI"/>
               </a:rPr>
-              <a:t>2.9</a:t>
+              <a:t>4.3</a:t>
             </a:r>
           </a:p>
         </p:txBody>

</xml_diff>